<commit_message>
Simplify ERD for onboarding explanation
Co-authored-by: K Varun Dev <K-Varun-dev@users.noreply.github.com>
</commit_message>
<xml_diff>
--- a/open_data_presentation.pptx
+++ b/open_data_presentation.pptx
@@ -5691,7 +5691,7 @@
               </a:defRPr>
             </a:pPr>
             <a:r>
-              <a:t>Planned ERD: source data, geography and derived insight</a:t>
+              <a:t>Simple ERD: four ideas we store</a:t>
             </a:r>
           </a:p>
         </p:txBody>
@@ -5704,18 +5704,18 @@
         </p:nvSpPr>
         <p:spPr>
           <a:xfrm>
-            <a:off x="914400" y="1005840"/>
-            <a:ext cx="2834640" cy="1051560"/>
+            <a:off x="457200" y="1097280"/>
+            <a:ext cx="5029200" cy="1234440"/>
           </a:xfrm>
           <a:prstGeom prst="roundRect">
             <a:avLst/>
           </a:prstGeom>
           <a:solidFill>
-            <a:srgbClr val="F8FAFC"/>
+            <a:srgbClr val="EEF2FF"/>
           </a:solidFill>
           <a:ln>
             <a:solidFill>
-              <a:srgbClr val="172554"/>
+              <a:srgbClr val="4F46E5"/>
             </a:solidFill>
           </a:ln>
         </p:spPr>
@@ -5738,7 +5738,7 @@
           <a:lstStyle/>
           <a:p>
             <a:pPr algn="ctr">
-              <a:defRPr b="1" sz="900">
+              <a:defRPr b="1" sz="1400">
                 <a:solidFill>
                   <a:srgbClr val="172554"/>
                 </a:solidFill>
@@ -5750,14 +5750,18 @@
           </a:p>
           <a:p>
             <a:pPr>
-              <a:defRPr sz="800">
+              <a:defRPr sz="1000">
                 <a:solidFill>
                   <a:srgbClr val="334155"/>
                 </a:solidFill>
               </a:defRPr>
             </a:pPr>
             <a:r>
-              <a:t>sensor_id, status, notes</a:t>
+              <a:t>Where in the CBD we measure</a:t>
+            </a:r>
+            <a:br/>
+            <a:r>
+              <a:t>(sensor_id, name, lat/lon, status)</a:t>
             </a:r>
           </a:p>
         </p:txBody>
@@ -5770,18 +5774,18 @@
         </p:nvSpPr>
         <p:spPr>
           <a:xfrm>
-            <a:off x="4572000" y="1005840"/>
-            <a:ext cx="2834640" cy="1051560"/>
+            <a:off x="457200" y="2606040"/>
+            <a:ext cx="5029200" cy="1234440"/>
           </a:xfrm>
           <a:prstGeom prst="roundRect">
             <a:avLst/>
           </a:prstGeom>
           <a:solidFill>
-            <a:srgbClr val="F8FAFC"/>
+            <a:srgbClr val="EEF2FF"/>
           </a:solidFill>
           <a:ln>
             <a:solidFill>
-              <a:srgbClr val="172554"/>
+              <a:srgbClr val="4F46E5"/>
             </a:solidFill>
           </a:ln>
         </p:spPr>
@@ -5804,26 +5808,30 @@
           <a:lstStyle/>
           <a:p>
             <a:pPr algn="ctr">
-              <a:defRPr b="1" sz="900">
+              <a:defRPr b="1" sz="1400">
                 <a:solidFill>
                   <a:srgbClr val="172554"/>
                 </a:solidFill>
               </a:defRPr>
             </a:pPr>
             <a:r>
-              <a:t>SENSOR_LOCATION_HISTORY</a:t>
+              <a:t>CROWD_READING</a:t>
             </a:r>
           </a:p>
           <a:p>
             <a:pPr>
-              <a:defRPr sz="800">
+              <a:defRPr sz="1000">
                 <a:solidFill>
                   <a:srgbClr val="334155"/>
                 </a:solidFill>
               </a:defRPr>
             </a:pPr>
             <a:r>
-              <a:t>location_id, sensor_id, lat/lon, valid_from/to</a:t>
+              <a:t>Raw open-data counts over time</a:t>
+            </a:r>
+            <a:br/>
+            <a:r>
+              <a:t>(sensor_id, recorded_at, count)</a:t>
             </a:r>
           </a:p>
         </p:txBody>
@@ -5836,272 +5844,8 @@
         </p:nvSpPr>
         <p:spPr>
           <a:xfrm>
-            <a:off x="8229600" y="1005840"/>
-            <a:ext cx="2834640" cy="1051560"/>
-          </a:xfrm>
-          <a:prstGeom prst="roundRect">
-            <a:avLst/>
-          </a:prstGeom>
-          <a:solidFill>
-            <a:srgbClr val="F8FAFC"/>
-          </a:solidFill>
-          <a:ln>
-            <a:solidFill>
-              <a:srgbClr val="172554"/>
-            </a:solidFill>
-          </a:ln>
-        </p:spPr>
-        <p:style>
-          <a:lnRef idx="1">
-            <a:schemeClr val="accent1"/>
-          </a:lnRef>
-          <a:fillRef idx="3">
-            <a:schemeClr val="accent1"/>
-          </a:fillRef>
-          <a:effectRef idx="2">
-            <a:schemeClr val="accent1"/>
-          </a:effectRef>
-          <a:fontRef idx="minor">
-            <a:schemeClr val="lt1"/>
-          </a:fontRef>
-        </p:style>
-        <p:txBody>
-          <a:bodyPr rtlCol="0" anchor="ctr"/>
-          <a:lstStyle/>
-          <a:p>
-            <a:pPr algn="ctr">
-              <a:defRPr b="1" sz="900">
-                <a:solidFill>
-                  <a:srgbClr val="172554"/>
-                </a:solidFill>
-              </a:defRPr>
-            </a:pPr>
-            <a:r>
-              <a:t>MINUTE_COUNT</a:t>
-            </a:r>
-          </a:p>
-          <a:p>
-            <a:pPr>
-              <a:defRPr sz="800">
-                <a:solidFill>
-                  <a:srgbClr val="334155"/>
-                </a:solidFill>
-              </a:defRPr>
-            </a:pPr>
-            <a:r>
-              <a:t>sensor_id, observed_at, totals, quality_status</a:t>
-            </a:r>
-          </a:p>
-        </p:txBody>
-      </p:sp>
-      <p:sp>
-        <p:nvSpPr>
-          <p:cNvPr id="6" name="Rounded Rectangle 5"/>
-          <p:cNvSpPr/>
-          <p:nvPr/>
-        </p:nvSpPr>
-        <p:spPr>
-          <a:xfrm>
-            <a:off x="914400" y="2331720"/>
-            <a:ext cx="2834640" cy="1051560"/>
-          </a:xfrm>
-          <a:prstGeom prst="roundRect">
-            <a:avLst/>
-          </a:prstGeom>
-          <a:solidFill>
-            <a:srgbClr val="F8FAFC"/>
-          </a:solidFill>
-          <a:ln>
-            <a:solidFill>
-              <a:srgbClr val="172554"/>
-            </a:solidFill>
-          </a:ln>
-        </p:spPr>
-        <p:style>
-          <a:lnRef idx="1">
-            <a:schemeClr val="accent1"/>
-          </a:lnRef>
-          <a:fillRef idx="3">
-            <a:schemeClr val="accent1"/>
-          </a:fillRef>
-          <a:effectRef idx="2">
-            <a:schemeClr val="accent1"/>
-          </a:effectRef>
-          <a:fontRef idx="minor">
-            <a:schemeClr val="lt1"/>
-          </a:fontRef>
-        </p:style>
-        <p:txBody>
-          <a:bodyPr rtlCol="0" anchor="ctr"/>
-          <a:lstStyle/>
-          <a:p>
-            <a:pPr algn="ctr">
-              <a:defRPr b="1" sz="900">
-                <a:solidFill>
-                  <a:srgbClr val="172554"/>
-                </a:solidFill>
-              </a:defRPr>
-            </a:pPr>
-            <a:r>
-              <a:t>HOURLY_COUNT</a:t>
-            </a:r>
-          </a:p>
-          <a:p>
-            <a:pPr>
-              <a:defRPr sz="800">
-                <a:solidFill>
-                  <a:srgbClr val="334155"/>
-                </a:solidFill>
-              </a:defRPr>
-            </a:pPr>
-            <a:r>
-              <a:t>sensor_id, observed_hour, total, quality_status</a:t>
-            </a:r>
-          </a:p>
-        </p:txBody>
-      </p:sp>
-      <p:sp>
-        <p:nvSpPr>
-          <p:cNvPr id="7" name="Rounded Rectangle 6"/>
-          <p:cNvSpPr/>
-          <p:nvPr/>
-        </p:nvSpPr>
-        <p:spPr>
-          <a:xfrm>
-            <a:off x="4572000" y="2331720"/>
-            <a:ext cx="2834640" cy="1051560"/>
-          </a:xfrm>
-          <a:prstGeom prst="roundRect">
-            <a:avLst/>
-          </a:prstGeom>
-          <a:solidFill>
-            <a:srgbClr val="F8FAFC"/>
-          </a:solidFill>
-          <a:ln>
-            <a:solidFill>
-              <a:srgbClr val="172554"/>
-            </a:solidFill>
-          </a:ln>
-        </p:spPr>
-        <p:style>
-          <a:lnRef idx="1">
-            <a:schemeClr val="accent1"/>
-          </a:lnRef>
-          <a:fillRef idx="3">
-            <a:schemeClr val="accent1"/>
-          </a:fillRef>
-          <a:effectRef idx="2">
-            <a:schemeClr val="accent1"/>
-          </a:effectRef>
-          <a:fontRef idx="minor">
-            <a:schemeClr val="lt1"/>
-          </a:fontRef>
-        </p:style>
-        <p:txBody>
-          <a:bodyPr rtlCol="0" anchor="ctr"/>
-          <a:lstStyle/>
-          <a:p>
-            <a:pPr algn="ctr">
-              <a:defRPr b="1" sz="900">
-                <a:solidFill>
-                  <a:srgbClr val="172554"/>
-                </a:solidFill>
-              </a:defRPr>
-            </a:pPr>
-            <a:r>
-              <a:t>REFUGE_CANDIDATE</a:t>
-            </a:r>
-          </a:p>
-          <a:p>
-            <a:pPr>
-              <a:defRPr sz="800">
-                <a:solidFill>
-                  <a:srgbClr val="334155"/>
-                </a:solidFill>
-              </a:defRPr>
-            </a:pPr>
-            <a:r>
-              <a:t>place_id, category, name, coords, validation</a:t>
-            </a:r>
-          </a:p>
-        </p:txBody>
-      </p:sp>
-      <p:sp>
-        <p:nvSpPr>
-          <p:cNvPr id="8" name="Rounded Rectangle 7"/>
-          <p:cNvSpPr/>
-          <p:nvPr/>
-        </p:nvSpPr>
-        <p:spPr>
-          <a:xfrm>
-            <a:off x="8229600" y="2331720"/>
-            <a:ext cx="2834640" cy="1051560"/>
-          </a:xfrm>
-          <a:prstGeom prst="roundRect">
-            <a:avLst/>
-          </a:prstGeom>
-          <a:solidFill>
-            <a:srgbClr val="F8FAFC"/>
-          </a:solidFill>
-          <a:ln>
-            <a:solidFill>
-              <a:srgbClr val="172554"/>
-            </a:solidFill>
-          </a:ln>
-        </p:spPr>
-        <p:style>
-          <a:lnRef idx="1">
-            <a:schemeClr val="accent1"/>
-          </a:lnRef>
-          <a:fillRef idx="3">
-            <a:schemeClr val="accent1"/>
-          </a:fillRef>
-          <a:effectRef idx="2">
-            <a:schemeClr val="accent1"/>
-          </a:effectRef>
-          <a:fontRef idx="minor">
-            <a:schemeClr val="lt1"/>
-          </a:fontRef>
-        </p:style>
-        <p:txBody>
-          <a:bodyPr rtlCol="0" anchor="ctr"/>
-          <a:lstStyle/>
-          <a:p>
-            <a:pPr algn="ctr">
-              <a:defRPr b="1" sz="900">
-                <a:solidFill>
-                  <a:srgbClr val="172554"/>
-                </a:solidFill>
-              </a:defRPr>
-            </a:pPr>
-            <a:r>
-              <a:t>ROAD_EDGE</a:t>
-            </a:r>
-          </a:p>
-          <a:p>
-            <a:pPr>
-              <a:defRPr sz="800">
-                <a:solidFill>
-                  <a:srgbClr val="334155"/>
-                </a:solidFill>
-              </a:defRPr>
-            </a:pPr>
-            <a:r>
-              <a:t>edge_id, from/to node, distance, walkability</a:t>
-            </a:r>
-          </a:p>
-        </p:txBody>
-      </p:sp>
-      <p:sp>
-        <p:nvSpPr>
-          <p:cNvPr id="9" name="Rounded Rectangle 8"/>
-          <p:cNvSpPr/>
-          <p:nvPr/>
-        </p:nvSpPr>
-        <p:spPr>
-          <a:xfrm>
-            <a:off x="2286000" y="3703320"/>
-            <a:ext cx="2834640" cy="1051560"/>
+            <a:off x="457200" y="4114800"/>
+            <a:ext cx="5029200" cy="1417320"/>
           </a:xfrm>
           <a:prstGeom prst="roundRect">
             <a:avLst/>
@@ -6134,50 +5878,58 @@
           <a:lstStyle/>
           <a:p>
             <a:pPr algn="ctr">
-              <a:defRPr b="1" sz="900">
+              <a:defRPr b="1" sz="1400">
                 <a:solidFill>
                   <a:srgbClr val="F97316"/>
                 </a:solidFill>
               </a:defRPr>
             </a:pPr>
             <a:r>
-              <a:t>CROWD_BASELINE</a:t>
+              <a:t>CROWD_SUMMARY</a:t>
             </a:r>
           </a:p>
           <a:p>
             <a:pPr>
-              <a:defRPr sz="800">
+              <a:defRPr sz="1000">
                 <a:solidFill>
                   <a:srgbClr val="334155"/>
                 </a:solidFill>
               </a:defRPr>
             </a:pPr>
             <a:r>
-              <a:t>sensor_id, weekday, hour, percentiles</a:t>
-            </a:r>
-          </a:p>
-        </p:txBody>
-      </p:sp>
-      <p:sp>
-        <p:nvSpPr>
-          <p:cNvPr id="10" name="Rounded Rectangle 9"/>
+              <a:t>What the user sees</a:t>
+            </a:r>
+            <a:br/>
+            <a:r>
+              <a:t>(sensor_id, crowd level, confidence,</a:t>
+            </a:r>
+            <a:br/>
+            <a:r>
+              <a:t>now / typical / next hour)</a:t>
+            </a:r>
+          </a:p>
+        </p:txBody>
+      </p:sp>
+      <p:sp>
+        <p:nvSpPr>
+          <p:cNvPr id="6" name="Rounded Rectangle 5"/>
           <p:cNvSpPr/>
           <p:nvPr/>
         </p:nvSpPr>
         <p:spPr>
           <a:xfrm>
-            <a:off x="6858000" y="3703320"/>
-            <a:ext cx="2834640" cy="1051560"/>
+            <a:off x="6583680" y="2011680"/>
+            <a:ext cx="4754880" cy="1234440"/>
           </a:xfrm>
           <a:prstGeom prst="roundRect">
             <a:avLst/>
           </a:prstGeom>
           <a:solidFill>
-            <a:srgbClr val="FFF7ED"/>
+            <a:srgbClr val="EEF2FF"/>
           </a:solidFill>
           <a:ln>
             <a:solidFill>
-              <a:srgbClr val="F97316"/>
+              <a:srgbClr val="4F46E5"/>
             </a:solidFill>
           </a:ln>
         </p:spPr>
@@ -6200,40 +5952,120 @@
           <a:lstStyle/>
           <a:p>
             <a:pPr algn="ctr">
-              <a:defRPr b="1" sz="900">
-                <a:solidFill>
-                  <a:srgbClr val="F97316"/>
-                </a:solidFill>
-              </a:defRPr>
-            </a:pPr>
-            <a:r>
-              <a:t>CROWD_PREDICTION</a:t>
+              <a:defRPr b="1" sz="1400">
+                <a:solidFill>
+                  <a:srgbClr val="172554"/>
+                </a:solidFill>
+              </a:defRPr>
+            </a:pPr>
+            <a:r>
+              <a:t>QUIET_PLACE</a:t>
             </a:r>
           </a:p>
           <a:p>
             <a:pPr>
-              <a:defRPr sz="800">
+              <a:defRPr sz="1000">
                 <a:solidFill>
                   <a:srgbClr val="334155"/>
                 </a:solidFill>
               </a:defRPr>
             </a:pPr>
             <a:r>
-              <a:t>sensor_id, target_hour, level, confidence</a:t>
-            </a:r>
-          </a:p>
-        </p:txBody>
-      </p:sp>
-      <p:sp>
-        <p:nvSpPr>
-          <p:cNvPr id="11" name="TextBox 10"/>
+              <a:t>Candidate break spots from landmarks</a:t>
+            </a:r>
+            <a:br/>
+            <a:r>
+              <a:t>(place_id, name, type, lat/lon)</a:t>
+            </a:r>
+          </a:p>
+        </p:txBody>
+      </p:sp>
+      <p:sp>
+        <p:nvSpPr>
+          <p:cNvPr id="7" name="Down Arrow 6"/>
+          <p:cNvSpPr/>
+          <p:nvPr/>
+        </p:nvSpPr>
+        <p:spPr>
+          <a:xfrm>
+            <a:off x="2286000" y="1600200"/>
+            <a:ext cx="320040" cy="502920"/>
+          </a:xfrm>
+          <a:prstGeom prst="downArrow">
+            <a:avLst/>
+          </a:prstGeom>
+          <a:solidFill/>
+        </p:spPr>
+        <p:style>
+          <a:lnRef idx="1">
+            <a:schemeClr val="accent1"/>
+          </a:lnRef>
+          <a:fillRef idx="3">
+            <a:schemeClr val="accent1"/>
+          </a:fillRef>
+          <a:effectRef idx="2">
+            <a:schemeClr val="accent1"/>
+          </a:effectRef>
+          <a:fontRef idx="minor">
+            <a:schemeClr val="lt1"/>
+          </a:fontRef>
+        </p:style>
+        <p:txBody>
+          <a:bodyPr rtlCol="0" anchor="ctr"/>
+          <a:lstStyle/>
+          <a:p>
+            <a:pPr algn="ctr"/>
+          </a:p>
+        </p:txBody>
+      </p:sp>
+      <p:sp>
+        <p:nvSpPr>
+          <p:cNvPr id="8" name="Down Arrow 7"/>
+          <p:cNvSpPr/>
+          <p:nvPr/>
+        </p:nvSpPr>
+        <p:spPr>
+          <a:xfrm>
+            <a:off x="2286000" y="3154680"/>
+            <a:ext cx="320040" cy="502920"/>
+          </a:xfrm>
+          <a:prstGeom prst="downArrow">
+            <a:avLst/>
+          </a:prstGeom>
+          <a:solidFill/>
+        </p:spPr>
+        <p:style>
+          <a:lnRef idx="1">
+            <a:schemeClr val="accent1"/>
+          </a:lnRef>
+          <a:fillRef idx="3">
+            <a:schemeClr val="accent1"/>
+          </a:fillRef>
+          <a:effectRef idx="2">
+            <a:schemeClr val="accent1"/>
+          </a:effectRef>
+          <a:fontRef idx="minor">
+            <a:schemeClr val="lt1"/>
+          </a:fontRef>
+        </p:style>
+        <p:txBody>
+          <a:bodyPr rtlCol="0" anchor="ctr"/>
+          <a:lstStyle/>
+          <a:p>
+            <a:pPr algn="ctr"/>
+          </a:p>
+        </p:txBody>
+      </p:sp>
+      <p:sp>
+        <p:nvSpPr>
+          <p:cNvPr id="9" name="TextBox 8"/>
           <p:cNvSpPr txBox="1"/>
           <p:nvPr/>
         </p:nvSpPr>
         <p:spPr>
           <a:xfrm>
-            <a:off x="320040" y="4892040"/>
-            <a:ext cx="11521440" cy="502920"/>
+            <a:off x="6583680" y="3657600"/>
+            <a:ext cx="5029200" cy="914400"/>
           </a:xfrm>
           <a:prstGeom prst="rect">
             <a:avLst/>
@@ -6257,7 +6089,60 @@
               </a:defRPr>
             </a:pPr>
             <a:r>
-              <a:t>Grey = imported facts. Orange = versioned analytical outputs. Location history prevents wrong map positions after sensor moves.</a:t>
+              <a:t>Quiet places are a separate map layer.</a:t>
+            </a:r>
+          </a:p>
+          <a:p>
+            <a:pPr algn="l">
+              <a:spcAft>
+                <a:spcPts val="400"/>
+              </a:spcAft>
+              <a:defRPr sz="1000" b="0">
+                <a:solidFill>
+                  <a:srgbClr val="334155"/>
+                </a:solidFill>
+              </a:defRPr>
+            </a:pPr>
+            <a:r>
+              <a:t>The app shows “nearby” refuges when crowd is high—no direct database link needed at onboarding.</a:t>
+            </a:r>
+          </a:p>
+        </p:txBody>
+      </p:sp>
+      <p:sp>
+        <p:nvSpPr>
+          <p:cNvPr id="10" name="TextBox 9"/>
+          <p:cNvSpPr txBox="1"/>
+          <p:nvPr/>
+        </p:nvSpPr>
+        <p:spPr>
+          <a:xfrm>
+            <a:off x="320040" y="5623560"/>
+            <a:ext cx="11521440" cy="411480"/>
+          </a:xfrm>
+          <a:prstGeom prst="rect">
+            <a:avLst/>
+          </a:prstGeom>
+          <a:noFill/>
+        </p:spPr>
+        <p:txBody>
+          <a:bodyPr wrap="square">
+            <a:spAutoFit/>
+          </a:bodyPr>
+          <a:lstStyle/>
+          <a:p>
+            <a:pPr algn="l">
+              <a:spcAft>
+                <a:spcPts val="400"/>
+              </a:spcAft>
+              <a:defRPr sz="1000" b="1">
+                <a:solidFill>
+                  <a:srgbClr val="172554"/>
+                </a:solidFill>
+              </a:defRPr>
+            </a:pPr>
+            <a:r>
+              <a:t>Walking routes use OpenStreetMap in the app layer; kept off this diagram to stay simple.</a:t>
             </a:r>
           </a:p>
         </p:txBody>

</xml_diff>